<commit_message>
release: align revised manuscript package for v1.0.4
</commit_message>
<xml_diff>
--- a/figures/generated/figure_2_chemical_subgroup_gain_editable.pptx
+++ b/figures/generated/figure_2_chemical_subgroup_gain_editable.pptx
@@ -3181,7 +3181,7 @@
                 </a:solidFill>
                 <a:latin typeface="Arial"/>
               </a:rPr>
-              <a:t>ΔRMSE = RMSE(DLG-Sol) − RMSE(component); negative values favor DLG-Sol</a:t>
+              <a:t>ΔRMSE = RMSE(DLG-Sol) − RMSE(component); negative values favour DLG-Sol</a:t>
             </a:r>
           </a:p>
         </p:txBody>
@@ -3195,7 +3195,7 @@
         <p:spPr>
           <a:xfrm>
             <a:off x="36000" y="381600"/>
-            <a:ext cx="522000" cy="100800"/>
+            <a:ext cx="666000" cy="100800"/>
           </a:xfrm>
           <a:prstGeom prst="rect">
             <a:avLst/>
@@ -3239,7 +3239,7 @@
         </p:nvSpPr>
         <p:spPr>
           <a:xfrm>
-            <a:off x="633600" y="381600"/>
+            <a:off x="777600" y="381600"/>
             <a:ext cx="468000" cy="100800"/>
           </a:xfrm>
           <a:prstGeom prst="rect">
@@ -3285,7 +3285,7 @@
         <p:spPr>
           <a:xfrm>
             <a:off x="50400" y="503999"/>
-            <a:ext cx="1080000" cy="464400"/>
+            <a:ext cx="1224000" cy="464400"/>
           </a:xfrm>
           <a:prstGeom prst="rect">
             <a:avLst/>
@@ -3330,7 +3330,7 @@
         <p:spPr>
           <a:xfrm>
             <a:off x="36000" y="503999"/>
-            <a:ext cx="522000" cy="464400"/>
+            <a:ext cx="666000" cy="464400"/>
           </a:xfrm>
           <a:prstGeom prst="rect">
             <a:avLst/>
@@ -3375,7 +3375,7 @@
         </p:nvSpPr>
         <p:spPr>
           <a:xfrm>
-            <a:off x="633600" y="503999"/>
+            <a:off x="777600" y="503999"/>
             <a:ext cx="468000" cy="154800"/>
           </a:xfrm>
           <a:prstGeom prst="rect">
@@ -3420,7 +3420,7 @@
         </p:nvSpPr>
         <p:spPr>
           <a:xfrm>
-            <a:off x="633600" y="658800"/>
+            <a:off x="777600" y="658800"/>
             <a:ext cx="468000" cy="154800"/>
           </a:xfrm>
           <a:prstGeom prst="rect">
@@ -3465,7 +3465,7 @@
         </p:nvSpPr>
         <p:spPr>
           <a:xfrm>
-            <a:off x="633600" y="813599"/>
+            <a:off x="777600" y="813599"/>
             <a:ext cx="468000" cy="154800"/>
           </a:xfrm>
           <a:prstGeom prst="rect">
@@ -3511,7 +3511,7 @@
         <p:spPr>
           <a:xfrm>
             <a:off x="50400" y="968400"/>
-            <a:ext cx="1080000" cy="464400"/>
+            <a:ext cx="1224000" cy="464400"/>
           </a:xfrm>
           <a:prstGeom prst="rect">
             <a:avLst/>
@@ -3556,7 +3556,7 @@
         <p:spPr>
           <a:xfrm>
             <a:off x="36000" y="968400"/>
-            <a:ext cx="522000" cy="464400"/>
+            <a:ext cx="666000" cy="464400"/>
           </a:xfrm>
           <a:prstGeom prst="rect">
             <a:avLst/>
@@ -3601,7 +3601,7 @@
         </p:nvSpPr>
         <p:spPr>
           <a:xfrm>
-            <a:off x="633600" y="968400"/>
+            <a:off x="777600" y="968400"/>
             <a:ext cx="468000" cy="154800"/>
           </a:xfrm>
           <a:prstGeom prst="rect">
@@ -3646,7 +3646,7 @@
         </p:nvSpPr>
         <p:spPr>
           <a:xfrm>
-            <a:off x="633600" y="1123200"/>
+            <a:off x="777600" y="1123200"/>
             <a:ext cx="468000" cy="154800"/>
           </a:xfrm>
           <a:prstGeom prst="rect">
@@ -3691,7 +3691,7 @@
         </p:nvSpPr>
         <p:spPr>
           <a:xfrm>
-            <a:off x="633600" y="1278000"/>
+            <a:off x="777600" y="1278000"/>
             <a:ext cx="468000" cy="154800"/>
           </a:xfrm>
           <a:prstGeom prst="rect">
@@ -3737,7 +3737,7 @@
         <p:spPr>
           <a:xfrm>
             <a:off x="50400" y="1432800"/>
-            <a:ext cx="1080000" cy="309600"/>
+            <a:ext cx="1224000" cy="309600"/>
           </a:xfrm>
           <a:prstGeom prst="rect">
             <a:avLst/>
@@ -3782,7 +3782,7 @@
         <p:spPr>
           <a:xfrm>
             <a:off x="36000" y="1432800"/>
-            <a:ext cx="522000" cy="309600"/>
+            <a:ext cx="666000" cy="309600"/>
           </a:xfrm>
           <a:prstGeom prst="rect">
             <a:avLst/>
@@ -3827,7 +3827,7 @@
         </p:nvSpPr>
         <p:spPr>
           <a:xfrm>
-            <a:off x="633600" y="1432800"/>
+            <a:off x="777600" y="1432800"/>
             <a:ext cx="468000" cy="154800"/>
           </a:xfrm>
           <a:prstGeom prst="rect">
@@ -3872,7 +3872,7 @@
         </p:nvSpPr>
         <p:spPr>
           <a:xfrm>
-            <a:off x="633600" y="1587600"/>
+            <a:off x="777600" y="1587600"/>
             <a:ext cx="468000" cy="154800"/>
           </a:xfrm>
           <a:prstGeom prst="rect">
@@ -3918,7 +3918,7 @@
         <p:spPr>
           <a:xfrm>
             <a:off x="50400" y="1742400"/>
-            <a:ext cx="1080000" cy="309600"/>
+            <a:ext cx="1224000" cy="309600"/>
           </a:xfrm>
           <a:prstGeom prst="rect">
             <a:avLst/>
@@ -3963,7 +3963,7 @@
         <p:spPr>
           <a:xfrm>
             <a:off x="36000" y="1742400"/>
-            <a:ext cx="522000" cy="309600"/>
+            <a:ext cx="666000" cy="309600"/>
           </a:xfrm>
           <a:prstGeom prst="rect">
             <a:avLst/>
@@ -4008,7 +4008,7 @@
         </p:nvSpPr>
         <p:spPr>
           <a:xfrm>
-            <a:off x="633600" y="1742400"/>
+            <a:off x="777600" y="1742400"/>
             <a:ext cx="468000" cy="154800"/>
           </a:xfrm>
           <a:prstGeom prst="rect">
@@ -4053,7 +4053,7 @@
         </p:nvSpPr>
         <p:spPr>
           <a:xfrm>
-            <a:off x="633600" y="1897199"/>
+            <a:off x="777600" y="1897199"/>
             <a:ext cx="468000" cy="154800"/>
           </a:xfrm>
           <a:prstGeom prst="rect">
@@ -4099,7 +4099,7 @@
         <p:spPr>
           <a:xfrm>
             <a:off x="50400" y="2051999"/>
-            <a:ext cx="1080000" cy="309600"/>
+            <a:ext cx="1224000" cy="309600"/>
           </a:xfrm>
           <a:prstGeom prst="rect">
             <a:avLst/>
@@ -4144,7 +4144,7 @@
         <p:spPr>
           <a:xfrm>
             <a:off x="36000" y="2051999"/>
-            <a:ext cx="522000" cy="309600"/>
+            <a:ext cx="666000" cy="309600"/>
           </a:xfrm>
           <a:prstGeom prst="rect">
             <a:avLst/>
@@ -4189,7 +4189,7 @@
         </p:nvSpPr>
         <p:spPr>
           <a:xfrm>
-            <a:off x="633600" y="2051999"/>
+            <a:off x="777600" y="2051999"/>
             <a:ext cx="468000" cy="154800"/>
           </a:xfrm>
           <a:prstGeom prst="rect">
@@ -4234,7 +4234,7 @@
         </p:nvSpPr>
         <p:spPr>
           <a:xfrm>
-            <a:off x="633600" y="2206799"/>
+            <a:off x="777600" y="2206799"/>
             <a:ext cx="468000" cy="154800"/>
           </a:xfrm>
           <a:prstGeom prst="rect">
@@ -4280,7 +4280,7 @@
         <p:spPr>
           <a:xfrm>
             <a:off x="50400" y="2361600"/>
-            <a:ext cx="1080000" cy="309600"/>
+            <a:ext cx="1224000" cy="309600"/>
           </a:xfrm>
           <a:prstGeom prst="rect">
             <a:avLst/>
@@ -4325,7 +4325,7 @@
         <p:spPr>
           <a:xfrm>
             <a:off x="36000" y="2361600"/>
-            <a:ext cx="522000" cy="309600"/>
+            <a:ext cx="666000" cy="309600"/>
           </a:xfrm>
           <a:prstGeom prst="rect">
             <a:avLst/>
@@ -4370,7 +4370,7 @@
         </p:nvSpPr>
         <p:spPr>
           <a:xfrm>
-            <a:off x="633600" y="2361600"/>
+            <a:off x="777600" y="2361600"/>
             <a:ext cx="468000" cy="154800"/>
           </a:xfrm>
           <a:prstGeom prst="rect">
@@ -4415,7 +4415,7 @@
         </p:nvSpPr>
         <p:spPr>
           <a:xfrm>
-            <a:off x="633600" y="2516400"/>
+            <a:off x="777600" y="2516400"/>
             <a:ext cx="468000" cy="154800"/>
           </a:xfrm>
           <a:prstGeom prst="rect">
@@ -4461,7 +4461,7 @@
         <p:spPr>
           <a:xfrm>
             <a:off x="50400" y="2671200"/>
-            <a:ext cx="1080000" cy="309600"/>
+            <a:ext cx="1224000" cy="309600"/>
           </a:xfrm>
           <a:prstGeom prst="rect">
             <a:avLst/>
@@ -4506,7 +4506,7 @@
         <p:spPr>
           <a:xfrm>
             <a:off x="36000" y="2671200"/>
-            <a:ext cx="522000" cy="309600"/>
+            <a:ext cx="666000" cy="309600"/>
           </a:xfrm>
           <a:prstGeom prst="rect">
             <a:avLst/>
@@ -4551,7 +4551,7 @@
         </p:nvSpPr>
         <p:spPr>
           <a:xfrm>
-            <a:off x="633600" y="2671200"/>
+            <a:off x="777600" y="2671200"/>
             <a:ext cx="468000" cy="154800"/>
           </a:xfrm>
           <a:prstGeom prst="rect">
@@ -4596,7 +4596,7 @@
         </p:nvSpPr>
         <p:spPr>
           <a:xfrm>
-            <a:off x="633600" y="2826000"/>
+            <a:off x="777600" y="2826000"/>
             <a:ext cx="468000" cy="154800"/>
           </a:xfrm>
           <a:prstGeom prst="rect">
@@ -4641,7 +4641,7 @@
         </p:nvSpPr>
         <p:spPr>
           <a:xfrm>
-            <a:off x="1152000" y="360000"/>
+            <a:off x="1296000" y="360000"/>
             <a:ext cx="1814400" cy="115200"/>
           </a:xfrm>
           <a:prstGeom prst="rect">
@@ -4686,7 +4686,7 @@
         </p:nvSpPr>
         <p:spPr>
           <a:xfrm>
-            <a:off x="1152000" y="503999"/>
+            <a:off x="1296000" y="503999"/>
             <a:ext cx="302400" cy="154800"/>
           </a:xfrm>
           <a:prstGeom prst="rect">
@@ -4731,7 +4731,7 @@
         </p:nvSpPr>
         <p:spPr>
           <a:xfrm>
-            <a:off x="1454400" y="503999"/>
+            <a:off x="1598400" y="503999"/>
             <a:ext cx="302400" cy="154800"/>
           </a:xfrm>
           <a:prstGeom prst="rect">
@@ -4776,7 +4776,7 @@
         </p:nvSpPr>
         <p:spPr>
           <a:xfrm>
-            <a:off x="1756800" y="503999"/>
+            <a:off x="1900800" y="503999"/>
             <a:ext cx="302400" cy="154800"/>
           </a:xfrm>
           <a:prstGeom prst="rect">
@@ -4821,7 +4821,7 @@
         </p:nvSpPr>
         <p:spPr>
           <a:xfrm>
-            <a:off x="2059200" y="503999"/>
+            <a:off x="2203200" y="503999"/>
             <a:ext cx="302400" cy="154800"/>
           </a:xfrm>
           <a:prstGeom prst="rect">
@@ -4866,7 +4866,7 @@
         </p:nvSpPr>
         <p:spPr>
           <a:xfrm>
-            <a:off x="2361600" y="503999"/>
+            <a:off x="2505600" y="503999"/>
             <a:ext cx="302400" cy="154800"/>
           </a:xfrm>
           <a:prstGeom prst="rect">
@@ -4911,7 +4911,7 @@
         </p:nvSpPr>
         <p:spPr>
           <a:xfrm>
-            <a:off x="2664000" y="503999"/>
+            <a:off x="2808000" y="503999"/>
             <a:ext cx="302400" cy="154800"/>
           </a:xfrm>
           <a:prstGeom prst="rect">
@@ -4956,7 +4956,7 @@
         </p:nvSpPr>
         <p:spPr>
           <a:xfrm>
-            <a:off x="1152000" y="658800"/>
+            <a:off x="1296000" y="658800"/>
             <a:ext cx="302400" cy="154800"/>
           </a:xfrm>
           <a:prstGeom prst="rect">
@@ -5001,7 +5001,7 @@
         </p:nvSpPr>
         <p:spPr>
           <a:xfrm>
-            <a:off x="1454400" y="658800"/>
+            <a:off x="1598400" y="658800"/>
             <a:ext cx="302400" cy="154800"/>
           </a:xfrm>
           <a:prstGeom prst="rect">
@@ -5046,7 +5046,7 @@
         </p:nvSpPr>
         <p:spPr>
           <a:xfrm>
-            <a:off x="1756800" y="658800"/>
+            <a:off x="1900800" y="658800"/>
             <a:ext cx="302400" cy="154800"/>
           </a:xfrm>
           <a:prstGeom prst="rect">
@@ -5091,7 +5091,7 @@
         </p:nvSpPr>
         <p:spPr>
           <a:xfrm>
-            <a:off x="2059200" y="658800"/>
+            <a:off x="2203200" y="658800"/>
             <a:ext cx="302400" cy="154800"/>
           </a:xfrm>
           <a:prstGeom prst="rect">
@@ -5136,7 +5136,7 @@
         </p:nvSpPr>
         <p:spPr>
           <a:xfrm>
-            <a:off x="2361600" y="658800"/>
+            <a:off x="2505600" y="658800"/>
             <a:ext cx="302400" cy="154800"/>
           </a:xfrm>
           <a:prstGeom prst="rect">
@@ -5181,7 +5181,7 @@
         </p:nvSpPr>
         <p:spPr>
           <a:xfrm>
-            <a:off x="2664000" y="658800"/>
+            <a:off x="2808000" y="658800"/>
             <a:ext cx="302400" cy="154800"/>
           </a:xfrm>
           <a:prstGeom prst="rect">
@@ -5226,7 +5226,7 @@
         </p:nvSpPr>
         <p:spPr>
           <a:xfrm>
-            <a:off x="1152000" y="813599"/>
+            <a:off x="1296000" y="813599"/>
             <a:ext cx="302400" cy="154800"/>
           </a:xfrm>
           <a:prstGeom prst="rect">
@@ -5271,7 +5271,7 @@
         </p:nvSpPr>
         <p:spPr>
           <a:xfrm>
-            <a:off x="1454400" y="813599"/>
+            <a:off x="1598400" y="813599"/>
             <a:ext cx="302400" cy="154800"/>
           </a:xfrm>
           <a:prstGeom prst="rect">
@@ -5316,7 +5316,7 @@
         </p:nvSpPr>
         <p:spPr>
           <a:xfrm>
-            <a:off x="1756800" y="813599"/>
+            <a:off x="1900800" y="813599"/>
             <a:ext cx="302400" cy="154800"/>
           </a:xfrm>
           <a:prstGeom prst="rect">
@@ -5361,7 +5361,7 @@
         </p:nvSpPr>
         <p:spPr>
           <a:xfrm>
-            <a:off x="2059200" y="813599"/>
+            <a:off x="2203200" y="813599"/>
             <a:ext cx="302400" cy="154800"/>
           </a:xfrm>
           <a:prstGeom prst="rect">
@@ -5406,7 +5406,7 @@
         </p:nvSpPr>
         <p:spPr>
           <a:xfrm>
-            <a:off x="2361600" y="813599"/>
+            <a:off x="2505600" y="813599"/>
             <a:ext cx="302400" cy="154800"/>
           </a:xfrm>
           <a:prstGeom prst="rect">
@@ -5451,7 +5451,7 @@
         </p:nvSpPr>
         <p:spPr>
           <a:xfrm>
-            <a:off x="2664000" y="813599"/>
+            <a:off x="2808000" y="813599"/>
             <a:ext cx="302400" cy="154800"/>
           </a:xfrm>
           <a:prstGeom prst="rect">
@@ -5496,7 +5496,7 @@
         </p:nvSpPr>
         <p:spPr>
           <a:xfrm>
-            <a:off x="1152000" y="968400"/>
+            <a:off x="1296000" y="968400"/>
             <a:ext cx="302400" cy="154800"/>
           </a:xfrm>
           <a:prstGeom prst="rect">
@@ -5541,7 +5541,7 @@
         </p:nvSpPr>
         <p:spPr>
           <a:xfrm>
-            <a:off x="1454400" y="968400"/>
+            <a:off x="1598400" y="968400"/>
             <a:ext cx="302400" cy="154800"/>
           </a:xfrm>
           <a:prstGeom prst="rect">
@@ -5586,7 +5586,7 @@
         </p:nvSpPr>
         <p:spPr>
           <a:xfrm>
-            <a:off x="1756800" y="968400"/>
+            <a:off x="1900800" y="968400"/>
             <a:ext cx="302400" cy="154800"/>
           </a:xfrm>
           <a:prstGeom prst="rect">
@@ -5631,7 +5631,7 @@
         </p:nvSpPr>
         <p:spPr>
           <a:xfrm>
-            <a:off x="2059200" y="968400"/>
+            <a:off x="2203200" y="968400"/>
             <a:ext cx="302400" cy="154800"/>
           </a:xfrm>
           <a:prstGeom prst="rect">
@@ -5676,7 +5676,7 @@
         </p:nvSpPr>
         <p:spPr>
           <a:xfrm>
-            <a:off x="2361600" y="968400"/>
+            <a:off x="2505600" y="968400"/>
             <a:ext cx="302400" cy="154800"/>
           </a:xfrm>
           <a:prstGeom prst="rect">
@@ -5721,7 +5721,7 @@
         </p:nvSpPr>
         <p:spPr>
           <a:xfrm>
-            <a:off x="2664000" y="968400"/>
+            <a:off x="2808000" y="968400"/>
             <a:ext cx="302400" cy="154800"/>
           </a:xfrm>
           <a:prstGeom prst="rect">
@@ -5766,7 +5766,7 @@
         </p:nvSpPr>
         <p:spPr>
           <a:xfrm>
-            <a:off x="1152000" y="1123200"/>
+            <a:off x="1296000" y="1123200"/>
             <a:ext cx="302400" cy="154800"/>
           </a:xfrm>
           <a:prstGeom prst="rect">
@@ -5811,7 +5811,7 @@
         </p:nvSpPr>
         <p:spPr>
           <a:xfrm>
-            <a:off x="1454400" y="1123200"/>
+            <a:off x="1598400" y="1123200"/>
             <a:ext cx="302400" cy="154800"/>
           </a:xfrm>
           <a:prstGeom prst="rect">
@@ -5856,7 +5856,7 @@
         </p:nvSpPr>
         <p:spPr>
           <a:xfrm>
-            <a:off x="1756800" y="1123200"/>
+            <a:off x="1900800" y="1123200"/>
             <a:ext cx="302400" cy="154800"/>
           </a:xfrm>
           <a:prstGeom prst="rect">
@@ -5901,7 +5901,7 @@
         </p:nvSpPr>
         <p:spPr>
           <a:xfrm>
-            <a:off x="2059200" y="1123200"/>
+            <a:off x="2203200" y="1123200"/>
             <a:ext cx="302400" cy="154800"/>
           </a:xfrm>
           <a:prstGeom prst="rect">
@@ -5946,7 +5946,7 @@
         </p:nvSpPr>
         <p:spPr>
           <a:xfrm>
-            <a:off x="2361600" y="1123200"/>
+            <a:off x="2505600" y="1123200"/>
             <a:ext cx="302400" cy="154800"/>
           </a:xfrm>
           <a:prstGeom prst="rect">
@@ -5991,7 +5991,7 @@
         </p:nvSpPr>
         <p:spPr>
           <a:xfrm>
-            <a:off x="2664000" y="1123200"/>
+            <a:off x="2808000" y="1123200"/>
             <a:ext cx="302400" cy="154800"/>
           </a:xfrm>
           <a:prstGeom prst="rect">
@@ -6036,7 +6036,7 @@
         </p:nvSpPr>
         <p:spPr>
           <a:xfrm>
-            <a:off x="1152000" y="1278000"/>
+            <a:off x="1296000" y="1278000"/>
             <a:ext cx="302400" cy="154800"/>
           </a:xfrm>
           <a:prstGeom prst="rect">
@@ -6081,7 +6081,7 @@
         </p:nvSpPr>
         <p:spPr>
           <a:xfrm>
-            <a:off x="1454400" y="1278000"/>
+            <a:off x="1598400" y="1278000"/>
             <a:ext cx="302400" cy="154800"/>
           </a:xfrm>
           <a:prstGeom prst="rect">
@@ -6126,7 +6126,7 @@
         </p:nvSpPr>
         <p:spPr>
           <a:xfrm>
-            <a:off x="1756800" y="1278000"/>
+            <a:off x="1900800" y="1278000"/>
             <a:ext cx="302400" cy="154800"/>
           </a:xfrm>
           <a:prstGeom prst="rect">
@@ -6171,7 +6171,7 @@
         </p:nvSpPr>
         <p:spPr>
           <a:xfrm>
-            <a:off x="2059200" y="1278000"/>
+            <a:off x="2203200" y="1278000"/>
             <a:ext cx="302400" cy="154800"/>
           </a:xfrm>
           <a:prstGeom prst="rect">
@@ -6216,7 +6216,7 @@
         </p:nvSpPr>
         <p:spPr>
           <a:xfrm>
-            <a:off x="2361600" y="1278000"/>
+            <a:off x="2505600" y="1278000"/>
             <a:ext cx="302400" cy="154800"/>
           </a:xfrm>
           <a:prstGeom prst="rect">
@@ -6261,7 +6261,7 @@
         </p:nvSpPr>
         <p:spPr>
           <a:xfrm>
-            <a:off x="2664000" y="1278000"/>
+            <a:off x="2808000" y="1278000"/>
             <a:ext cx="302400" cy="154800"/>
           </a:xfrm>
           <a:prstGeom prst="rect">
@@ -6306,7 +6306,7 @@
         </p:nvSpPr>
         <p:spPr>
           <a:xfrm>
-            <a:off x="1152000" y="1432800"/>
+            <a:off x="1296000" y="1432800"/>
             <a:ext cx="302400" cy="154800"/>
           </a:xfrm>
           <a:prstGeom prst="rect">
@@ -6351,7 +6351,7 @@
         </p:nvSpPr>
         <p:spPr>
           <a:xfrm>
-            <a:off x="1454400" y="1432800"/>
+            <a:off x="1598400" y="1432800"/>
             <a:ext cx="302400" cy="154800"/>
           </a:xfrm>
           <a:prstGeom prst="rect">
@@ -6396,7 +6396,7 @@
         </p:nvSpPr>
         <p:spPr>
           <a:xfrm>
-            <a:off x="1756800" y="1432800"/>
+            <a:off x="1900800" y="1432800"/>
             <a:ext cx="302400" cy="154800"/>
           </a:xfrm>
           <a:prstGeom prst="rect">
@@ -6441,7 +6441,7 @@
         </p:nvSpPr>
         <p:spPr>
           <a:xfrm>
-            <a:off x="2059200" y="1432800"/>
+            <a:off x="2203200" y="1432800"/>
             <a:ext cx="302400" cy="154800"/>
           </a:xfrm>
           <a:prstGeom prst="rect">
@@ -6486,7 +6486,7 @@
         </p:nvSpPr>
         <p:spPr>
           <a:xfrm>
-            <a:off x="2361600" y="1432800"/>
+            <a:off x="2505600" y="1432800"/>
             <a:ext cx="302400" cy="154800"/>
           </a:xfrm>
           <a:prstGeom prst="rect">
@@ -6531,7 +6531,7 @@
         </p:nvSpPr>
         <p:spPr>
           <a:xfrm>
-            <a:off x="2664000" y="1432800"/>
+            <a:off x="2808000" y="1432800"/>
             <a:ext cx="302400" cy="154800"/>
           </a:xfrm>
           <a:prstGeom prst="rect">
@@ -6576,7 +6576,7 @@
         </p:nvSpPr>
         <p:spPr>
           <a:xfrm>
-            <a:off x="1152000" y="1587600"/>
+            <a:off x="1296000" y="1587600"/>
             <a:ext cx="302400" cy="154800"/>
           </a:xfrm>
           <a:prstGeom prst="rect">
@@ -6621,7 +6621,7 @@
         </p:nvSpPr>
         <p:spPr>
           <a:xfrm>
-            <a:off x="1454400" y="1587600"/>
+            <a:off x="1598400" y="1587600"/>
             <a:ext cx="302400" cy="154800"/>
           </a:xfrm>
           <a:prstGeom prst="rect">
@@ -6666,7 +6666,7 @@
         </p:nvSpPr>
         <p:spPr>
           <a:xfrm>
-            <a:off x="1756800" y="1587600"/>
+            <a:off x="1900800" y="1587600"/>
             <a:ext cx="302400" cy="154800"/>
           </a:xfrm>
           <a:prstGeom prst="rect">
@@ -6711,7 +6711,7 @@
         </p:nvSpPr>
         <p:spPr>
           <a:xfrm>
-            <a:off x="2059200" y="1587600"/>
+            <a:off x="2203200" y="1587600"/>
             <a:ext cx="302400" cy="154800"/>
           </a:xfrm>
           <a:prstGeom prst="rect">
@@ -6756,7 +6756,7 @@
         </p:nvSpPr>
         <p:spPr>
           <a:xfrm>
-            <a:off x="2361600" y="1587600"/>
+            <a:off x="2505600" y="1587600"/>
             <a:ext cx="302400" cy="154800"/>
           </a:xfrm>
           <a:prstGeom prst="rect">
@@ -6801,7 +6801,7 @@
         </p:nvSpPr>
         <p:spPr>
           <a:xfrm>
-            <a:off x="2664000" y="1587600"/>
+            <a:off x="2808000" y="1587600"/>
             <a:ext cx="302400" cy="154800"/>
           </a:xfrm>
           <a:prstGeom prst="rect">
@@ -6846,7 +6846,7 @@
         </p:nvSpPr>
         <p:spPr>
           <a:xfrm>
-            <a:off x="1152000" y="1742400"/>
+            <a:off x="1296000" y="1742400"/>
             <a:ext cx="302400" cy="154800"/>
           </a:xfrm>
           <a:prstGeom prst="rect">
@@ -6891,7 +6891,7 @@
         </p:nvSpPr>
         <p:spPr>
           <a:xfrm>
-            <a:off x="1454400" y="1742400"/>
+            <a:off x="1598400" y="1742400"/>
             <a:ext cx="302400" cy="154800"/>
           </a:xfrm>
           <a:prstGeom prst="rect">
@@ -6936,7 +6936,7 @@
         </p:nvSpPr>
         <p:spPr>
           <a:xfrm>
-            <a:off x="1756800" y="1742400"/>
+            <a:off x="1900800" y="1742400"/>
             <a:ext cx="302400" cy="154800"/>
           </a:xfrm>
           <a:prstGeom prst="rect">
@@ -6981,7 +6981,7 @@
         </p:nvSpPr>
         <p:spPr>
           <a:xfrm>
-            <a:off x="2059200" y="1742400"/>
+            <a:off x="2203200" y="1742400"/>
             <a:ext cx="302400" cy="154800"/>
           </a:xfrm>
           <a:prstGeom prst="rect">
@@ -7026,7 +7026,7 @@
         </p:nvSpPr>
         <p:spPr>
           <a:xfrm>
-            <a:off x="2361600" y="1742400"/>
+            <a:off x="2505600" y="1742400"/>
             <a:ext cx="302400" cy="154800"/>
           </a:xfrm>
           <a:prstGeom prst="rect">
@@ -7071,7 +7071,7 @@
         </p:nvSpPr>
         <p:spPr>
           <a:xfrm>
-            <a:off x="2664000" y="1742400"/>
+            <a:off x="2808000" y="1742400"/>
             <a:ext cx="302400" cy="154800"/>
           </a:xfrm>
           <a:prstGeom prst="rect">
@@ -7116,7 +7116,7 @@
         </p:nvSpPr>
         <p:spPr>
           <a:xfrm>
-            <a:off x="1152000" y="1897199"/>
+            <a:off x="1296000" y="1897199"/>
             <a:ext cx="302400" cy="154800"/>
           </a:xfrm>
           <a:prstGeom prst="rect">
@@ -7161,7 +7161,7 @@
         </p:nvSpPr>
         <p:spPr>
           <a:xfrm>
-            <a:off x="1454400" y="1897199"/>
+            <a:off x="1598400" y="1897199"/>
             <a:ext cx="302400" cy="154800"/>
           </a:xfrm>
           <a:prstGeom prst="rect">
@@ -7206,7 +7206,7 @@
         </p:nvSpPr>
         <p:spPr>
           <a:xfrm>
-            <a:off x="1756800" y="1897199"/>
+            <a:off x="1900800" y="1897199"/>
             <a:ext cx="302400" cy="154800"/>
           </a:xfrm>
           <a:prstGeom prst="rect">
@@ -7251,7 +7251,7 @@
         </p:nvSpPr>
         <p:spPr>
           <a:xfrm>
-            <a:off x="2059200" y="1897199"/>
+            <a:off x="2203200" y="1897199"/>
             <a:ext cx="302400" cy="154800"/>
           </a:xfrm>
           <a:prstGeom prst="rect">
@@ -7296,7 +7296,7 @@
         </p:nvSpPr>
         <p:spPr>
           <a:xfrm>
-            <a:off x="2361600" y="1897199"/>
+            <a:off x="2505600" y="1897199"/>
             <a:ext cx="302400" cy="154800"/>
           </a:xfrm>
           <a:prstGeom prst="rect">
@@ -7341,7 +7341,7 @@
         </p:nvSpPr>
         <p:spPr>
           <a:xfrm>
-            <a:off x="2664000" y="1897199"/>
+            <a:off x="2808000" y="1897199"/>
             <a:ext cx="302400" cy="154800"/>
           </a:xfrm>
           <a:prstGeom prst="rect">
@@ -7386,7 +7386,7 @@
         </p:nvSpPr>
         <p:spPr>
           <a:xfrm>
-            <a:off x="1152000" y="2051999"/>
+            <a:off x="1296000" y="2051999"/>
             <a:ext cx="302400" cy="154800"/>
           </a:xfrm>
           <a:prstGeom prst="rect">
@@ -7431,7 +7431,7 @@
         </p:nvSpPr>
         <p:spPr>
           <a:xfrm>
-            <a:off x="1454400" y="2051999"/>
+            <a:off x="1598400" y="2051999"/>
             <a:ext cx="302400" cy="154800"/>
           </a:xfrm>
           <a:prstGeom prst="rect">
@@ -7476,7 +7476,7 @@
         </p:nvSpPr>
         <p:spPr>
           <a:xfrm>
-            <a:off x="1756800" y="2051999"/>
+            <a:off x="1900800" y="2051999"/>
             <a:ext cx="302400" cy="154800"/>
           </a:xfrm>
           <a:prstGeom prst="rect">
@@ -7521,7 +7521,7 @@
         </p:nvSpPr>
         <p:spPr>
           <a:xfrm>
-            <a:off x="2059200" y="2051999"/>
+            <a:off x="2203200" y="2051999"/>
             <a:ext cx="302400" cy="154800"/>
           </a:xfrm>
           <a:prstGeom prst="rect">
@@ -7566,7 +7566,7 @@
         </p:nvSpPr>
         <p:spPr>
           <a:xfrm>
-            <a:off x="2361600" y="2051999"/>
+            <a:off x="2505600" y="2051999"/>
             <a:ext cx="302400" cy="154800"/>
           </a:xfrm>
           <a:prstGeom prst="rect">
@@ -7611,7 +7611,7 @@
         </p:nvSpPr>
         <p:spPr>
           <a:xfrm>
-            <a:off x="2664000" y="2051999"/>
+            <a:off x="2808000" y="2051999"/>
             <a:ext cx="302400" cy="154800"/>
           </a:xfrm>
           <a:prstGeom prst="rect">
@@ -7656,7 +7656,7 @@
         </p:nvSpPr>
         <p:spPr>
           <a:xfrm>
-            <a:off x="1152000" y="2206799"/>
+            <a:off x="1296000" y="2206799"/>
             <a:ext cx="302400" cy="154800"/>
           </a:xfrm>
           <a:prstGeom prst="rect">
@@ -7701,7 +7701,7 @@
         </p:nvSpPr>
         <p:spPr>
           <a:xfrm>
-            <a:off x="1454400" y="2206799"/>
+            <a:off x="1598400" y="2206799"/>
             <a:ext cx="302400" cy="154800"/>
           </a:xfrm>
           <a:prstGeom prst="rect">
@@ -7746,7 +7746,7 @@
         </p:nvSpPr>
         <p:spPr>
           <a:xfrm>
-            <a:off x="1756800" y="2206799"/>
+            <a:off x="1900800" y="2206799"/>
             <a:ext cx="302400" cy="154800"/>
           </a:xfrm>
           <a:prstGeom prst="rect">
@@ -7791,7 +7791,7 @@
         </p:nvSpPr>
         <p:spPr>
           <a:xfrm>
-            <a:off x="2059200" y="2206799"/>
+            <a:off x="2203200" y="2206799"/>
             <a:ext cx="302400" cy="154800"/>
           </a:xfrm>
           <a:prstGeom prst="rect">
@@ -7836,7 +7836,7 @@
         </p:nvSpPr>
         <p:spPr>
           <a:xfrm>
-            <a:off x="2361600" y="2206799"/>
+            <a:off x="2505600" y="2206799"/>
             <a:ext cx="302400" cy="154800"/>
           </a:xfrm>
           <a:prstGeom prst="rect">
@@ -7881,7 +7881,7 @@
         </p:nvSpPr>
         <p:spPr>
           <a:xfrm>
-            <a:off x="2664000" y="2206799"/>
+            <a:off x="2808000" y="2206799"/>
             <a:ext cx="302400" cy="154800"/>
           </a:xfrm>
           <a:prstGeom prst="rect">
@@ -7926,7 +7926,7 @@
         </p:nvSpPr>
         <p:spPr>
           <a:xfrm>
-            <a:off x="1152000" y="2361600"/>
+            <a:off x="1296000" y="2361600"/>
             <a:ext cx="302400" cy="154800"/>
           </a:xfrm>
           <a:prstGeom prst="rect">
@@ -7971,7 +7971,7 @@
         </p:nvSpPr>
         <p:spPr>
           <a:xfrm>
-            <a:off x="1454400" y="2361600"/>
+            <a:off x="1598400" y="2361600"/>
             <a:ext cx="302400" cy="154800"/>
           </a:xfrm>
           <a:prstGeom prst="rect">
@@ -8016,7 +8016,7 @@
         </p:nvSpPr>
         <p:spPr>
           <a:xfrm>
-            <a:off x="1756800" y="2361600"/>
+            <a:off x="1900800" y="2361600"/>
             <a:ext cx="302400" cy="154800"/>
           </a:xfrm>
           <a:prstGeom prst="rect">
@@ -8061,7 +8061,7 @@
         </p:nvSpPr>
         <p:spPr>
           <a:xfrm>
-            <a:off x="2059200" y="2361600"/>
+            <a:off x="2203200" y="2361600"/>
             <a:ext cx="302400" cy="154800"/>
           </a:xfrm>
           <a:prstGeom prst="rect">
@@ -8106,7 +8106,7 @@
         </p:nvSpPr>
         <p:spPr>
           <a:xfrm>
-            <a:off x="2361600" y="2361600"/>
+            <a:off x="2505600" y="2361600"/>
             <a:ext cx="302400" cy="154800"/>
           </a:xfrm>
           <a:prstGeom prst="rect">
@@ -8151,7 +8151,7 @@
         </p:nvSpPr>
         <p:spPr>
           <a:xfrm>
-            <a:off x="2664000" y="2361600"/>
+            <a:off x="2808000" y="2361600"/>
             <a:ext cx="302400" cy="154800"/>
           </a:xfrm>
           <a:prstGeom prst="rect">
@@ -8196,7 +8196,7 @@
         </p:nvSpPr>
         <p:spPr>
           <a:xfrm>
-            <a:off x="1152000" y="2516400"/>
+            <a:off x="1296000" y="2516400"/>
             <a:ext cx="302400" cy="154800"/>
           </a:xfrm>
           <a:prstGeom prst="rect">
@@ -8241,7 +8241,7 @@
         </p:nvSpPr>
         <p:spPr>
           <a:xfrm>
-            <a:off x="1454400" y="2516400"/>
+            <a:off x="1598400" y="2516400"/>
             <a:ext cx="302400" cy="154800"/>
           </a:xfrm>
           <a:prstGeom prst="rect">
@@ -8286,7 +8286,7 @@
         </p:nvSpPr>
         <p:spPr>
           <a:xfrm>
-            <a:off x="1756800" y="2516400"/>
+            <a:off x="1900800" y="2516400"/>
             <a:ext cx="302400" cy="154800"/>
           </a:xfrm>
           <a:prstGeom prst="rect">
@@ -8331,7 +8331,7 @@
         </p:nvSpPr>
         <p:spPr>
           <a:xfrm>
-            <a:off x="2059200" y="2516400"/>
+            <a:off x="2203200" y="2516400"/>
             <a:ext cx="302400" cy="154800"/>
           </a:xfrm>
           <a:prstGeom prst="rect">
@@ -8376,7 +8376,7 @@
         </p:nvSpPr>
         <p:spPr>
           <a:xfrm>
-            <a:off x="2361600" y="2516400"/>
+            <a:off x="2505600" y="2516400"/>
             <a:ext cx="302400" cy="154800"/>
           </a:xfrm>
           <a:prstGeom prst="rect">
@@ -8421,7 +8421,7 @@
         </p:nvSpPr>
         <p:spPr>
           <a:xfrm>
-            <a:off x="2664000" y="2516400"/>
+            <a:off x="2808000" y="2516400"/>
             <a:ext cx="302400" cy="154800"/>
           </a:xfrm>
           <a:prstGeom prst="rect">
@@ -8466,7 +8466,7 @@
         </p:nvSpPr>
         <p:spPr>
           <a:xfrm>
-            <a:off x="1152000" y="2671200"/>
+            <a:off x="1296000" y="2671200"/>
             <a:ext cx="302400" cy="154800"/>
           </a:xfrm>
           <a:prstGeom prst="rect">
@@ -8511,7 +8511,7 @@
         </p:nvSpPr>
         <p:spPr>
           <a:xfrm>
-            <a:off x="1454400" y="2671200"/>
+            <a:off x="1598400" y="2671200"/>
             <a:ext cx="302400" cy="154800"/>
           </a:xfrm>
           <a:prstGeom prst="rect">
@@ -8556,7 +8556,7 @@
         </p:nvSpPr>
         <p:spPr>
           <a:xfrm>
-            <a:off x="1756800" y="2671200"/>
+            <a:off x="1900800" y="2671200"/>
             <a:ext cx="302400" cy="154800"/>
           </a:xfrm>
           <a:prstGeom prst="rect">
@@ -8601,7 +8601,7 @@
         </p:nvSpPr>
         <p:spPr>
           <a:xfrm>
-            <a:off x="2059200" y="2671200"/>
+            <a:off x="2203200" y="2671200"/>
             <a:ext cx="302400" cy="154800"/>
           </a:xfrm>
           <a:prstGeom prst="rect">
@@ -8646,7 +8646,7 @@
         </p:nvSpPr>
         <p:spPr>
           <a:xfrm>
-            <a:off x="2361600" y="2671200"/>
+            <a:off x="2505600" y="2671200"/>
             <a:ext cx="302400" cy="154800"/>
           </a:xfrm>
           <a:prstGeom prst="rect">
@@ -8691,7 +8691,7 @@
         </p:nvSpPr>
         <p:spPr>
           <a:xfrm>
-            <a:off x="2664000" y="2671200"/>
+            <a:off x="2808000" y="2671200"/>
             <a:ext cx="302400" cy="154800"/>
           </a:xfrm>
           <a:prstGeom prst="rect">
@@ -8736,7 +8736,7 @@
         </p:nvSpPr>
         <p:spPr>
           <a:xfrm>
-            <a:off x="1152000" y="2826000"/>
+            <a:off x="1296000" y="2826000"/>
             <a:ext cx="302400" cy="154800"/>
           </a:xfrm>
           <a:prstGeom prst="rect">
@@ -8781,7 +8781,7 @@
         </p:nvSpPr>
         <p:spPr>
           <a:xfrm>
-            <a:off x="1454400" y="2826000"/>
+            <a:off x="1598400" y="2826000"/>
             <a:ext cx="302400" cy="154800"/>
           </a:xfrm>
           <a:prstGeom prst="rect">
@@ -8826,7 +8826,7 @@
         </p:nvSpPr>
         <p:spPr>
           <a:xfrm>
-            <a:off x="1756800" y="2826000"/>
+            <a:off x="1900800" y="2826000"/>
             <a:ext cx="302400" cy="154800"/>
           </a:xfrm>
           <a:prstGeom prst="rect">
@@ -8871,7 +8871,7 @@
         </p:nvSpPr>
         <p:spPr>
           <a:xfrm>
-            <a:off x="2059200" y="2826000"/>
+            <a:off x="2203200" y="2826000"/>
             <a:ext cx="302400" cy="154800"/>
           </a:xfrm>
           <a:prstGeom prst="rect">
@@ -8916,7 +8916,7 @@
         </p:nvSpPr>
         <p:spPr>
           <a:xfrm>
-            <a:off x="2361600" y="2826000"/>
+            <a:off x="2505600" y="2826000"/>
             <a:ext cx="302400" cy="154800"/>
           </a:xfrm>
           <a:prstGeom prst="rect">
@@ -8961,7 +8961,7 @@
         </p:nvSpPr>
         <p:spPr>
           <a:xfrm>
-            <a:off x="2664000" y="2826000"/>
+            <a:off x="2808000" y="2826000"/>
             <a:ext cx="302400" cy="154800"/>
           </a:xfrm>
           <a:prstGeom prst="rect">
@@ -9006,7 +9006,7 @@
         </p:nvSpPr>
         <p:spPr>
           <a:xfrm>
-            <a:off x="1152000" y="503999"/>
+            <a:off x="1296000" y="503999"/>
             <a:ext cx="1814400" cy="2476800"/>
           </a:xfrm>
           <a:prstGeom prst="rect">
@@ -9049,7 +9049,7 @@
         </p:nvCxnSpPr>
         <p:spPr>
           <a:xfrm>
-            <a:off x="1152000" y="968400"/>
+            <a:off x="1296000" y="968400"/>
             <a:ext cx="1814400" cy="0"/>
           </a:xfrm>
           <a:prstGeom prst="line">
@@ -9084,7 +9084,7 @@
         </p:nvCxnSpPr>
         <p:spPr>
           <a:xfrm>
-            <a:off x="1152000" y="1432800"/>
+            <a:off x="1296000" y="1432800"/>
             <a:ext cx="1814400" cy="0"/>
           </a:xfrm>
           <a:prstGeom prst="line">
@@ -9119,7 +9119,7 @@
         </p:nvCxnSpPr>
         <p:spPr>
           <a:xfrm>
-            <a:off x="1152000" y="1742400"/>
+            <a:off x="1296000" y="1742400"/>
             <a:ext cx="1814400" cy="0"/>
           </a:xfrm>
           <a:prstGeom prst="line">
@@ -9154,7 +9154,7 @@
         </p:nvCxnSpPr>
         <p:spPr>
           <a:xfrm>
-            <a:off x="1152000" y="2051999"/>
+            <a:off x="1296000" y="2051999"/>
             <a:ext cx="1814400" cy="0"/>
           </a:xfrm>
           <a:prstGeom prst="line">
@@ -9189,7 +9189,7 @@
         </p:nvCxnSpPr>
         <p:spPr>
           <a:xfrm>
-            <a:off x="1152000" y="2361600"/>
+            <a:off x="1296000" y="2361600"/>
             <a:ext cx="1814400" cy="0"/>
           </a:xfrm>
           <a:prstGeom prst="line">
@@ -9224,7 +9224,7 @@
         </p:nvCxnSpPr>
         <p:spPr>
           <a:xfrm>
-            <a:off x="1152000" y="2671200"/>
+            <a:off x="1296000" y="2671200"/>
             <a:ext cx="1814400" cy="0"/>
           </a:xfrm>
           <a:prstGeom prst="line">
@@ -9259,7 +9259,7 @@
         </p:nvSpPr>
         <p:spPr>
           <a:xfrm rot="18900000">
-            <a:off x="1044000" y="2987999"/>
+            <a:off x="1188000" y="2987999"/>
             <a:ext cx="453600" cy="201600"/>
           </a:xfrm>
           <a:prstGeom prst="rect">
@@ -9305,7 +9305,7 @@
         </p:nvSpPr>
         <p:spPr>
           <a:xfrm rot="18900000">
-            <a:off x="1346400" y="2987999"/>
+            <a:off x="1490400" y="2987999"/>
             <a:ext cx="453600" cy="201600"/>
           </a:xfrm>
           <a:prstGeom prst="rect">
@@ -9351,7 +9351,7 @@
         </p:nvSpPr>
         <p:spPr>
           <a:xfrm rot="18900000">
-            <a:off x="1648800" y="2987999"/>
+            <a:off x="1792800" y="2987999"/>
             <a:ext cx="453600" cy="201600"/>
           </a:xfrm>
           <a:prstGeom prst="rect">
@@ -9397,7 +9397,7 @@
         </p:nvSpPr>
         <p:spPr>
           <a:xfrm rot="18900000">
-            <a:off x="1951200" y="2987999"/>
+            <a:off x="2095200" y="2987999"/>
             <a:ext cx="453600" cy="201600"/>
           </a:xfrm>
           <a:prstGeom prst="rect">
@@ -9444,7 +9444,7 @@
         </p:nvSpPr>
         <p:spPr>
           <a:xfrm rot="18900000">
-            <a:off x="2253600" y="2987999"/>
+            <a:off x="2397600" y="2987999"/>
             <a:ext cx="453600" cy="201600"/>
           </a:xfrm>
           <a:prstGeom prst="rect">
@@ -9491,7 +9491,7 @@
         </p:nvSpPr>
         <p:spPr>
           <a:xfrm rot="18900000">
-            <a:off x="2556000" y="2987999"/>
+            <a:off x="2700000" y="2987999"/>
             <a:ext cx="453600" cy="201600"/>
           </a:xfrm>
           <a:prstGeom prst="rect">
@@ -9538,7 +9538,7 @@
         </p:nvSpPr>
         <p:spPr>
           <a:xfrm>
-            <a:off x="3139200" y="360000"/>
+            <a:off x="3283200" y="360000"/>
             <a:ext cx="1814400" cy="115200"/>
           </a:xfrm>
           <a:prstGeom prst="rect">
@@ -9583,7 +9583,7 @@
         </p:nvSpPr>
         <p:spPr>
           <a:xfrm>
-            <a:off x="3139200" y="503999"/>
+            <a:off x="3283200" y="503999"/>
             <a:ext cx="302400" cy="154800"/>
           </a:xfrm>
           <a:prstGeom prst="rect">
@@ -9628,7 +9628,7 @@
         </p:nvSpPr>
         <p:spPr>
           <a:xfrm>
-            <a:off x="3441600" y="503999"/>
+            <a:off x="3585600" y="503999"/>
             <a:ext cx="302400" cy="154800"/>
           </a:xfrm>
           <a:prstGeom prst="rect">
@@ -9673,7 +9673,7 @@
         </p:nvSpPr>
         <p:spPr>
           <a:xfrm>
-            <a:off x="3744000" y="503999"/>
+            <a:off x="3888000" y="503999"/>
             <a:ext cx="302400" cy="154800"/>
           </a:xfrm>
           <a:prstGeom prst="rect">
@@ -9718,7 +9718,7 @@
         </p:nvSpPr>
         <p:spPr>
           <a:xfrm>
-            <a:off x="4046400" y="503999"/>
+            <a:off x="4190400" y="503999"/>
             <a:ext cx="302400" cy="154800"/>
           </a:xfrm>
           <a:prstGeom prst="rect">
@@ -9763,7 +9763,7 @@
         </p:nvSpPr>
         <p:spPr>
           <a:xfrm>
-            <a:off x="4348800" y="503999"/>
+            <a:off x="4492800" y="503999"/>
             <a:ext cx="302400" cy="154800"/>
           </a:xfrm>
           <a:prstGeom prst="rect">
@@ -9808,7 +9808,7 @@
         </p:nvSpPr>
         <p:spPr>
           <a:xfrm>
-            <a:off x="4651200" y="503999"/>
+            <a:off x="4795200" y="503999"/>
             <a:ext cx="302400" cy="154800"/>
           </a:xfrm>
           <a:prstGeom prst="rect">
@@ -9853,7 +9853,7 @@
         </p:nvSpPr>
         <p:spPr>
           <a:xfrm>
-            <a:off x="3139200" y="658800"/>
+            <a:off x="3283200" y="658800"/>
             <a:ext cx="302400" cy="154800"/>
           </a:xfrm>
           <a:prstGeom prst="rect">
@@ -9898,7 +9898,7 @@
         </p:nvSpPr>
         <p:spPr>
           <a:xfrm>
-            <a:off x="3441600" y="658800"/>
+            <a:off x="3585600" y="658800"/>
             <a:ext cx="302400" cy="154800"/>
           </a:xfrm>
           <a:prstGeom prst="rect">
@@ -9943,7 +9943,7 @@
         </p:nvSpPr>
         <p:spPr>
           <a:xfrm>
-            <a:off x="3744000" y="658800"/>
+            <a:off x="3888000" y="658800"/>
             <a:ext cx="302400" cy="154800"/>
           </a:xfrm>
           <a:prstGeom prst="rect">
@@ -9988,7 +9988,7 @@
         </p:nvSpPr>
         <p:spPr>
           <a:xfrm>
-            <a:off x="4046400" y="658800"/>
+            <a:off x="4190400" y="658800"/>
             <a:ext cx="302400" cy="154800"/>
           </a:xfrm>
           <a:prstGeom prst="rect">
@@ -10033,7 +10033,7 @@
         </p:nvSpPr>
         <p:spPr>
           <a:xfrm>
-            <a:off x="4348800" y="658800"/>
+            <a:off x="4492800" y="658800"/>
             <a:ext cx="302400" cy="154800"/>
           </a:xfrm>
           <a:prstGeom prst="rect">
@@ -10078,7 +10078,7 @@
         </p:nvSpPr>
         <p:spPr>
           <a:xfrm>
-            <a:off x="4651200" y="658800"/>
+            <a:off x="4795200" y="658800"/>
             <a:ext cx="302400" cy="154800"/>
           </a:xfrm>
           <a:prstGeom prst="rect">
@@ -10123,7 +10123,7 @@
         </p:nvSpPr>
         <p:spPr>
           <a:xfrm>
-            <a:off x="3139200" y="813599"/>
+            <a:off x="3283200" y="813599"/>
             <a:ext cx="302400" cy="154800"/>
           </a:xfrm>
           <a:prstGeom prst="rect">
@@ -10168,7 +10168,7 @@
         </p:nvSpPr>
         <p:spPr>
           <a:xfrm>
-            <a:off x="3441600" y="813599"/>
+            <a:off x="3585600" y="813599"/>
             <a:ext cx="302400" cy="154800"/>
           </a:xfrm>
           <a:prstGeom prst="rect">
@@ -10213,7 +10213,7 @@
         </p:nvSpPr>
         <p:spPr>
           <a:xfrm>
-            <a:off x="3744000" y="813599"/>
+            <a:off x="3888000" y="813599"/>
             <a:ext cx="302400" cy="154800"/>
           </a:xfrm>
           <a:prstGeom prst="rect">
@@ -10258,7 +10258,7 @@
         </p:nvSpPr>
         <p:spPr>
           <a:xfrm>
-            <a:off x="4046400" y="813599"/>
+            <a:off x="4190400" y="813599"/>
             <a:ext cx="302400" cy="154800"/>
           </a:xfrm>
           <a:prstGeom prst="rect">
@@ -10303,7 +10303,7 @@
         </p:nvSpPr>
         <p:spPr>
           <a:xfrm>
-            <a:off x="4348800" y="813599"/>
+            <a:off x="4492800" y="813599"/>
             <a:ext cx="302400" cy="154800"/>
           </a:xfrm>
           <a:prstGeom prst="rect">
@@ -10348,7 +10348,7 @@
         </p:nvSpPr>
         <p:spPr>
           <a:xfrm>
-            <a:off x="4651200" y="813599"/>
+            <a:off x="4795200" y="813599"/>
             <a:ext cx="302400" cy="154800"/>
           </a:xfrm>
           <a:prstGeom prst="rect">
@@ -10393,7 +10393,7 @@
         </p:nvSpPr>
         <p:spPr>
           <a:xfrm>
-            <a:off x="3139200" y="968400"/>
+            <a:off x="3283200" y="968400"/>
             <a:ext cx="302400" cy="154800"/>
           </a:xfrm>
           <a:prstGeom prst="rect">
@@ -10438,7 +10438,7 @@
         </p:nvSpPr>
         <p:spPr>
           <a:xfrm>
-            <a:off x="3441600" y="968400"/>
+            <a:off x="3585600" y="968400"/>
             <a:ext cx="302400" cy="154800"/>
           </a:xfrm>
           <a:prstGeom prst="rect">
@@ -10483,7 +10483,7 @@
         </p:nvSpPr>
         <p:spPr>
           <a:xfrm>
-            <a:off x="3744000" y="968400"/>
+            <a:off x="3888000" y="968400"/>
             <a:ext cx="302400" cy="154800"/>
           </a:xfrm>
           <a:prstGeom prst="rect">
@@ -10528,7 +10528,7 @@
         </p:nvSpPr>
         <p:spPr>
           <a:xfrm>
-            <a:off x="4046400" y="968400"/>
+            <a:off x="4190400" y="968400"/>
             <a:ext cx="302400" cy="154800"/>
           </a:xfrm>
           <a:prstGeom prst="rect">
@@ -10573,7 +10573,7 @@
         </p:nvSpPr>
         <p:spPr>
           <a:xfrm>
-            <a:off x="4348800" y="968400"/>
+            <a:off x="4492800" y="968400"/>
             <a:ext cx="302400" cy="154800"/>
           </a:xfrm>
           <a:prstGeom prst="rect">
@@ -10618,7 +10618,7 @@
         </p:nvSpPr>
         <p:spPr>
           <a:xfrm>
-            <a:off x="4651200" y="968400"/>
+            <a:off x="4795200" y="968400"/>
             <a:ext cx="302400" cy="154800"/>
           </a:xfrm>
           <a:prstGeom prst="rect">
@@ -10663,7 +10663,7 @@
         </p:nvSpPr>
         <p:spPr>
           <a:xfrm>
-            <a:off x="3139200" y="1123200"/>
+            <a:off x="3283200" y="1123200"/>
             <a:ext cx="302400" cy="154800"/>
           </a:xfrm>
           <a:prstGeom prst="rect">
@@ -10708,7 +10708,7 @@
         </p:nvSpPr>
         <p:spPr>
           <a:xfrm>
-            <a:off x="3441600" y="1123200"/>
+            <a:off x="3585600" y="1123200"/>
             <a:ext cx="302400" cy="154800"/>
           </a:xfrm>
           <a:prstGeom prst="rect">
@@ -10753,7 +10753,7 @@
         </p:nvSpPr>
         <p:spPr>
           <a:xfrm>
-            <a:off x="3744000" y="1123200"/>
+            <a:off x="3888000" y="1123200"/>
             <a:ext cx="302400" cy="154800"/>
           </a:xfrm>
           <a:prstGeom prst="rect">
@@ -10798,7 +10798,7 @@
         </p:nvSpPr>
         <p:spPr>
           <a:xfrm>
-            <a:off x="4046400" y="1123200"/>
+            <a:off x="4190400" y="1123200"/>
             <a:ext cx="302400" cy="154800"/>
           </a:xfrm>
           <a:prstGeom prst="rect">
@@ -10843,7 +10843,7 @@
         </p:nvSpPr>
         <p:spPr>
           <a:xfrm>
-            <a:off x="4348800" y="1123200"/>
+            <a:off x="4492800" y="1123200"/>
             <a:ext cx="302400" cy="154800"/>
           </a:xfrm>
           <a:prstGeom prst="rect">
@@ -10888,7 +10888,7 @@
         </p:nvSpPr>
         <p:spPr>
           <a:xfrm>
-            <a:off x="4651200" y="1123200"/>
+            <a:off x="4795200" y="1123200"/>
             <a:ext cx="302400" cy="154800"/>
           </a:xfrm>
           <a:prstGeom prst="rect">
@@ -10933,7 +10933,7 @@
         </p:nvSpPr>
         <p:spPr>
           <a:xfrm>
-            <a:off x="3139200" y="1278000"/>
+            <a:off x="3283200" y="1278000"/>
             <a:ext cx="302400" cy="154800"/>
           </a:xfrm>
           <a:prstGeom prst="rect">
@@ -10978,7 +10978,7 @@
         </p:nvSpPr>
         <p:spPr>
           <a:xfrm>
-            <a:off x="3441600" y="1278000"/>
+            <a:off x="3585600" y="1278000"/>
             <a:ext cx="302400" cy="154800"/>
           </a:xfrm>
           <a:prstGeom prst="rect">
@@ -11023,7 +11023,7 @@
         </p:nvSpPr>
         <p:spPr>
           <a:xfrm>
-            <a:off x="3744000" y="1278000"/>
+            <a:off x="3888000" y="1278000"/>
             <a:ext cx="302400" cy="154800"/>
           </a:xfrm>
           <a:prstGeom prst="rect">
@@ -11068,7 +11068,7 @@
         </p:nvSpPr>
         <p:spPr>
           <a:xfrm>
-            <a:off x="4046400" y="1278000"/>
+            <a:off x="4190400" y="1278000"/>
             <a:ext cx="302400" cy="154800"/>
           </a:xfrm>
           <a:prstGeom prst="rect">
@@ -11113,7 +11113,7 @@
         </p:nvSpPr>
         <p:spPr>
           <a:xfrm>
-            <a:off x="4348800" y="1278000"/>
+            <a:off x="4492800" y="1278000"/>
             <a:ext cx="302400" cy="154800"/>
           </a:xfrm>
           <a:prstGeom prst="rect">
@@ -11158,7 +11158,7 @@
         </p:nvSpPr>
         <p:spPr>
           <a:xfrm>
-            <a:off x="4651200" y="1278000"/>
+            <a:off x="4795200" y="1278000"/>
             <a:ext cx="302400" cy="154800"/>
           </a:xfrm>
           <a:prstGeom prst="rect">
@@ -11203,7 +11203,7 @@
         </p:nvSpPr>
         <p:spPr>
           <a:xfrm>
-            <a:off x="3139200" y="1432800"/>
+            <a:off x="3283200" y="1432800"/>
             <a:ext cx="302400" cy="154800"/>
           </a:xfrm>
           <a:prstGeom prst="rect">
@@ -11248,7 +11248,7 @@
         </p:nvSpPr>
         <p:spPr>
           <a:xfrm>
-            <a:off x="3441600" y="1432800"/>
+            <a:off x="3585600" y="1432800"/>
             <a:ext cx="302400" cy="154800"/>
           </a:xfrm>
           <a:prstGeom prst="rect">
@@ -11293,7 +11293,7 @@
         </p:nvSpPr>
         <p:spPr>
           <a:xfrm>
-            <a:off x="3744000" y="1432800"/>
+            <a:off x="3888000" y="1432800"/>
             <a:ext cx="302400" cy="154800"/>
           </a:xfrm>
           <a:prstGeom prst="rect">
@@ -11338,7 +11338,7 @@
         </p:nvSpPr>
         <p:spPr>
           <a:xfrm>
-            <a:off x="4046400" y="1432800"/>
+            <a:off x="4190400" y="1432800"/>
             <a:ext cx="302400" cy="154800"/>
           </a:xfrm>
           <a:prstGeom prst="rect">
@@ -11383,7 +11383,7 @@
         </p:nvSpPr>
         <p:spPr>
           <a:xfrm>
-            <a:off x="4348800" y="1432800"/>
+            <a:off x="4492800" y="1432800"/>
             <a:ext cx="302400" cy="154800"/>
           </a:xfrm>
           <a:prstGeom prst="rect">
@@ -11428,7 +11428,7 @@
         </p:nvSpPr>
         <p:spPr>
           <a:xfrm>
-            <a:off x="4651200" y="1432800"/>
+            <a:off x="4795200" y="1432800"/>
             <a:ext cx="302400" cy="154800"/>
           </a:xfrm>
           <a:prstGeom prst="rect">
@@ -11473,7 +11473,7 @@
         </p:nvSpPr>
         <p:spPr>
           <a:xfrm>
-            <a:off x="3139200" y="1587600"/>
+            <a:off x="3283200" y="1587600"/>
             <a:ext cx="302400" cy="154800"/>
           </a:xfrm>
           <a:prstGeom prst="rect">
@@ -11518,7 +11518,7 @@
         </p:nvSpPr>
         <p:spPr>
           <a:xfrm>
-            <a:off x="3441600" y="1587600"/>
+            <a:off x="3585600" y="1587600"/>
             <a:ext cx="302400" cy="154800"/>
           </a:xfrm>
           <a:prstGeom prst="rect">
@@ -11563,7 +11563,7 @@
         </p:nvSpPr>
         <p:spPr>
           <a:xfrm>
-            <a:off x="3744000" y="1587600"/>
+            <a:off x="3888000" y="1587600"/>
             <a:ext cx="302400" cy="154800"/>
           </a:xfrm>
           <a:prstGeom prst="rect">
@@ -11608,7 +11608,7 @@
         </p:nvSpPr>
         <p:spPr>
           <a:xfrm>
-            <a:off x="4046400" y="1587600"/>
+            <a:off x="4190400" y="1587600"/>
             <a:ext cx="302400" cy="154800"/>
           </a:xfrm>
           <a:prstGeom prst="rect">
@@ -11653,7 +11653,7 @@
         </p:nvSpPr>
         <p:spPr>
           <a:xfrm>
-            <a:off x="4348800" y="1587600"/>
+            <a:off x="4492800" y="1587600"/>
             <a:ext cx="302400" cy="154800"/>
           </a:xfrm>
           <a:prstGeom prst="rect">
@@ -11698,7 +11698,7 @@
         </p:nvSpPr>
         <p:spPr>
           <a:xfrm>
-            <a:off x="4651200" y="1587600"/>
+            <a:off x="4795200" y="1587600"/>
             <a:ext cx="302400" cy="154800"/>
           </a:xfrm>
           <a:prstGeom prst="rect">
@@ -11743,7 +11743,7 @@
         </p:nvSpPr>
         <p:spPr>
           <a:xfrm>
-            <a:off x="3139200" y="1742400"/>
+            <a:off x="3283200" y="1742400"/>
             <a:ext cx="302400" cy="154800"/>
           </a:xfrm>
           <a:prstGeom prst="rect">
@@ -11788,7 +11788,7 @@
         </p:nvSpPr>
         <p:spPr>
           <a:xfrm>
-            <a:off x="3441600" y="1742400"/>
+            <a:off x="3585600" y="1742400"/>
             <a:ext cx="302400" cy="154800"/>
           </a:xfrm>
           <a:prstGeom prst="rect">
@@ -11833,7 +11833,7 @@
         </p:nvSpPr>
         <p:spPr>
           <a:xfrm>
-            <a:off x="3744000" y="1742400"/>
+            <a:off x="3888000" y="1742400"/>
             <a:ext cx="302400" cy="154800"/>
           </a:xfrm>
           <a:prstGeom prst="rect">
@@ -11878,7 +11878,7 @@
         </p:nvSpPr>
         <p:spPr>
           <a:xfrm>
-            <a:off x="4046400" y="1742400"/>
+            <a:off x="4190400" y="1742400"/>
             <a:ext cx="302400" cy="154800"/>
           </a:xfrm>
           <a:prstGeom prst="rect">
@@ -11923,7 +11923,7 @@
         </p:nvSpPr>
         <p:spPr>
           <a:xfrm>
-            <a:off x="4348800" y="1742400"/>
+            <a:off x="4492800" y="1742400"/>
             <a:ext cx="302400" cy="154800"/>
           </a:xfrm>
           <a:prstGeom prst="rect">
@@ -11968,7 +11968,7 @@
         </p:nvSpPr>
         <p:spPr>
           <a:xfrm>
-            <a:off x="4651200" y="1742400"/>
+            <a:off x="4795200" y="1742400"/>
             <a:ext cx="302400" cy="154800"/>
           </a:xfrm>
           <a:prstGeom prst="rect">
@@ -12013,7 +12013,7 @@
         </p:nvSpPr>
         <p:spPr>
           <a:xfrm>
-            <a:off x="3139200" y="1897199"/>
+            <a:off x="3283200" y="1897199"/>
             <a:ext cx="302400" cy="154800"/>
           </a:xfrm>
           <a:prstGeom prst="rect">
@@ -12058,7 +12058,7 @@
         </p:nvSpPr>
         <p:spPr>
           <a:xfrm>
-            <a:off x="3441600" y="1897199"/>
+            <a:off x="3585600" y="1897199"/>
             <a:ext cx="302400" cy="154800"/>
           </a:xfrm>
           <a:prstGeom prst="rect">
@@ -12103,7 +12103,7 @@
         </p:nvSpPr>
         <p:spPr>
           <a:xfrm>
-            <a:off x="3744000" y="1897199"/>
+            <a:off x="3888000" y="1897199"/>
             <a:ext cx="302400" cy="154800"/>
           </a:xfrm>
           <a:prstGeom prst="rect">
@@ -12148,7 +12148,7 @@
         </p:nvSpPr>
         <p:spPr>
           <a:xfrm>
-            <a:off x="4046400" y="1897199"/>
+            <a:off x="4190400" y="1897199"/>
             <a:ext cx="302400" cy="154800"/>
           </a:xfrm>
           <a:prstGeom prst="rect">
@@ -12193,7 +12193,7 @@
         </p:nvSpPr>
         <p:spPr>
           <a:xfrm>
-            <a:off x="4348800" y="1897199"/>
+            <a:off x="4492800" y="1897199"/>
             <a:ext cx="302400" cy="154800"/>
           </a:xfrm>
           <a:prstGeom prst="rect">
@@ -12238,7 +12238,7 @@
         </p:nvSpPr>
         <p:spPr>
           <a:xfrm>
-            <a:off x="4651200" y="1897199"/>
+            <a:off x="4795200" y="1897199"/>
             <a:ext cx="302400" cy="154800"/>
           </a:xfrm>
           <a:prstGeom prst="rect">
@@ -12283,7 +12283,7 @@
         </p:nvSpPr>
         <p:spPr>
           <a:xfrm>
-            <a:off x="3139200" y="2051999"/>
+            <a:off x="3283200" y="2051999"/>
             <a:ext cx="302400" cy="154800"/>
           </a:xfrm>
           <a:prstGeom prst="rect">
@@ -12328,7 +12328,7 @@
         </p:nvSpPr>
         <p:spPr>
           <a:xfrm>
-            <a:off x="3441600" y="2051999"/>
+            <a:off x="3585600" y="2051999"/>
             <a:ext cx="302400" cy="154800"/>
           </a:xfrm>
           <a:prstGeom prst="rect">
@@ -12373,7 +12373,7 @@
         </p:nvSpPr>
         <p:spPr>
           <a:xfrm>
-            <a:off x="3744000" y="2051999"/>
+            <a:off x="3888000" y="2051999"/>
             <a:ext cx="302400" cy="154800"/>
           </a:xfrm>
           <a:prstGeom prst="rect">
@@ -12418,7 +12418,7 @@
         </p:nvSpPr>
         <p:spPr>
           <a:xfrm>
-            <a:off x="4046400" y="2051999"/>
+            <a:off x="4190400" y="2051999"/>
             <a:ext cx="302400" cy="154800"/>
           </a:xfrm>
           <a:prstGeom prst="rect">
@@ -12463,7 +12463,7 @@
         </p:nvSpPr>
         <p:spPr>
           <a:xfrm>
-            <a:off x="4348800" y="2051999"/>
+            <a:off x="4492800" y="2051999"/>
             <a:ext cx="302400" cy="154800"/>
           </a:xfrm>
           <a:prstGeom prst="rect">
@@ -12508,7 +12508,7 @@
         </p:nvSpPr>
         <p:spPr>
           <a:xfrm>
-            <a:off x="4651200" y="2051999"/>
+            <a:off x="4795200" y="2051999"/>
             <a:ext cx="302400" cy="154800"/>
           </a:xfrm>
           <a:prstGeom prst="rect">
@@ -12553,7 +12553,7 @@
         </p:nvSpPr>
         <p:spPr>
           <a:xfrm>
-            <a:off x="3139200" y="2206799"/>
+            <a:off x="3283200" y="2206799"/>
             <a:ext cx="302400" cy="154800"/>
           </a:xfrm>
           <a:prstGeom prst="rect">
@@ -12598,7 +12598,7 @@
         </p:nvSpPr>
         <p:spPr>
           <a:xfrm>
-            <a:off x="3441600" y="2206799"/>
+            <a:off x="3585600" y="2206799"/>
             <a:ext cx="302400" cy="154800"/>
           </a:xfrm>
           <a:prstGeom prst="rect">
@@ -12643,7 +12643,7 @@
         </p:nvSpPr>
         <p:spPr>
           <a:xfrm>
-            <a:off x="3744000" y="2206799"/>
+            <a:off x="3888000" y="2206799"/>
             <a:ext cx="302400" cy="154800"/>
           </a:xfrm>
           <a:prstGeom prst="rect">
@@ -12688,7 +12688,7 @@
         </p:nvSpPr>
         <p:spPr>
           <a:xfrm>
-            <a:off x="4046400" y="2206799"/>
+            <a:off x="4190400" y="2206799"/>
             <a:ext cx="302400" cy="154800"/>
           </a:xfrm>
           <a:prstGeom prst="rect">
@@ -12733,7 +12733,7 @@
         </p:nvSpPr>
         <p:spPr>
           <a:xfrm>
-            <a:off x="4348800" y="2206799"/>
+            <a:off x="4492800" y="2206799"/>
             <a:ext cx="302400" cy="154800"/>
           </a:xfrm>
           <a:prstGeom prst="rect">
@@ -12778,7 +12778,7 @@
         </p:nvSpPr>
         <p:spPr>
           <a:xfrm>
-            <a:off x="4651200" y="2206799"/>
+            <a:off x="4795200" y="2206799"/>
             <a:ext cx="302400" cy="154800"/>
           </a:xfrm>
           <a:prstGeom prst="rect">
@@ -12823,7 +12823,7 @@
         </p:nvSpPr>
         <p:spPr>
           <a:xfrm>
-            <a:off x="3139200" y="2361600"/>
+            <a:off x="3283200" y="2361600"/>
             <a:ext cx="302400" cy="154800"/>
           </a:xfrm>
           <a:prstGeom prst="rect">
@@ -12868,7 +12868,7 @@
         </p:nvSpPr>
         <p:spPr>
           <a:xfrm>
-            <a:off x="3441600" y="2361600"/>
+            <a:off x="3585600" y="2361600"/>
             <a:ext cx="302400" cy="154800"/>
           </a:xfrm>
           <a:prstGeom prst="rect">
@@ -12913,7 +12913,7 @@
         </p:nvSpPr>
         <p:spPr>
           <a:xfrm>
-            <a:off x="3744000" y="2361600"/>
+            <a:off x="3888000" y="2361600"/>
             <a:ext cx="302400" cy="154800"/>
           </a:xfrm>
           <a:prstGeom prst="rect">
@@ -12958,7 +12958,7 @@
         </p:nvSpPr>
         <p:spPr>
           <a:xfrm>
-            <a:off x="4046400" y="2361600"/>
+            <a:off x="4190400" y="2361600"/>
             <a:ext cx="302400" cy="154800"/>
           </a:xfrm>
           <a:prstGeom prst="rect">
@@ -13003,7 +13003,7 @@
         </p:nvSpPr>
         <p:spPr>
           <a:xfrm>
-            <a:off x="4348800" y="2361600"/>
+            <a:off x="4492800" y="2361600"/>
             <a:ext cx="302400" cy="154800"/>
           </a:xfrm>
           <a:prstGeom prst="rect">
@@ -13048,7 +13048,7 @@
         </p:nvSpPr>
         <p:spPr>
           <a:xfrm>
-            <a:off x="4651200" y="2361600"/>
+            <a:off x="4795200" y="2361600"/>
             <a:ext cx="302400" cy="154800"/>
           </a:xfrm>
           <a:prstGeom prst="rect">
@@ -13093,7 +13093,7 @@
         </p:nvSpPr>
         <p:spPr>
           <a:xfrm>
-            <a:off x="3139200" y="2516400"/>
+            <a:off x="3283200" y="2516400"/>
             <a:ext cx="302400" cy="154800"/>
           </a:xfrm>
           <a:prstGeom prst="rect">
@@ -13138,7 +13138,7 @@
         </p:nvSpPr>
         <p:spPr>
           <a:xfrm>
-            <a:off x="3441600" y="2516400"/>
+            <a:off x="3585600" y="2516400"/>
             <a:ext cx="302400" cy="154800"/>
           </a:xfrm>
           <a:prstGeom prst="rect">
@@ -13183,7 +13183,7 @@
         </p:nvSpPr>
         <p:spPr>
           <a:xfrm>
-            <a:off x="3744000" y="2516400"/>
+            <a:off x="3888000" y="2516400"/>
             <a:ext cx="302400" cy="154800"/>
           </a:xfrm>
           <a:prstGeom prst="rect">
@@ -13228,7 +13228,7 @@
         </p:nvSpPr>
         <p:spPr>
           <a:xfrm>
-            <a:off x="4046400" y="2516400"/>
+            <a:off x="4190400" y="2516400"/>
             <a:ext cx="302400" cy="154800"/>
           </a:xfrm>
           <a:prstGeom prst="rect">
@@ -13273,7 +13273,7 @@
         </p:nvSpPr>
         <p:spPr>
           <a:xfrm>
-            <a:off x="4348800" y="2516400"/>
+            <a:off x="4492800" y="2516400"/>
             <a:ext cx="302400" cy="154800"/>
           </a:xfrm>
           <a:prstGeom prst="rect">
@@ -13318,7 +13318,7 @@
         </p:nvSpPr>
         <p:spPr>
           <a:xfrm>
-            <a:off x="4651200" y="2516400"/>
+            <a:off x="4795200" y="2516400"/>
             <a:ext cx="302400" cy="154800"/>
           </a:xfrm>
           <a:prstGeom prst="rect">
@@ -13363,7 +13363,7 @@
         </p:nvSpPr>
         <p:spPr>
           <a:xfrm>
-            <a:off x="3139200" y="2671200"/>
+            <a:off x="3283200" y="2671200"/>
             <a:ext cx="302400" cy="154800"/>
           </a:xfrm>
           <a:prstGeom prst="rect">
@@ -13408,7 +13408,7 @@
         </p:nvSpPr>
         <p:spPr>
           <a:xfrm>
-            <a:off x="3441600" y="2671200"/>
+            <a:off x="3585600" y="2671200"/>
             <a:ext cx="302400" cy="154800"/>
           </a:xfrm>
           <a:prstGeom prst="rect">
@@ -13453,7 +13453,7 @@
         </p:nvSpPr>
         <p:spPr>
           <a:xfrm>
-            <a:off x="3744000" y="2671200"/>
+            <a:off x="3888000" y="2671200"/>
             <a:ext cx="302400" cy="154800"/>
           </a:xfrm>
           <a:prstGeom prst="rect">
@@ -13498,7 +13498,7 @@
         </p:nvSpPr>
         <p:spPr>
           <a:xfrm>
-            <a:off x="4046400" y="2671200"/>
+            <a:off x="4190400" y="2671200"/>
             <a:ext cx="302400" cy="154800"/>
           </a:xfrm>
           <a:prstGeom prst="rect">
@@ -13543,7 +13543,7 @@
         </p:nvSpPr>
         <p:spPr>
           <a:xfrm>
-            <a:off x="4348800" y="2671200"/>
+            <a:off x="4492800" y="2671200"/>
             <a:ext cx="302400" cy="154800"/>
           </a:xfrm>
           <a:prstGeom prst="rect">
@@ -13588,7 +13588,7 @@
         </p:nvSpPr>
         <p:spPr>
           <a:xfrm>
-            <a:off x="4651200" y="2671200"/>
+            <a:off x="4795200" y="2671200"/>
             <a:ext cx="302400" cy="154800"/>
           </a:xfrm>
           <a:prstGeom prst="rect">
@@ -13633,7 +13633,7 @@
         </p:nvSpPr>
         <p:spPr>
           <a:xfrm>
-            <a:off x="3139200" y="2826000"/>
+            <a:off x="3283200" y="2826000"/>
             <a:ext cx="302400" cy="154800"/>
           </a:xfrm>
           <a:prstGeom prst="rect">
@@ -13678,7 +13678,7 @@
         </p:nvSpPr>
         <p:spPr>
           <a:xfrm>
-            <a:off x="3441600" y="2826000"/>
+            <a:off x="3585600" y="2826000"/>
             <a:ext cx="302400" cy="154800"/>
           </a:xfrm>
           <a:prstGeom prst="rect">
@@ -13723,7 +13723,7 @@
         </p:nvSpPr>
         <p:spPr>
           <a:xfrm>
-            <a:off x="3744000" y="2826000"/>
+            <a:off x="3888000" y="2826000"/>
             <a:ext cx="302400" cy="154800"/>
           </a:xfrm>
           <a:prstGeom prst="rect">
@@ -13768,7 +13768,7 @@
         </p:nvSpPr>
         <p:spPr>
           <a:xfrm>
-            <a:off x="4046400" y="2826000"/>
+            <a:off x="4190400" y="2826000"/>
             <a:ext cx="302400" cy="154800"/>
           </a:xfrm>
           <a:prstGeom prst="rect">
@@ -13813,7 +13813,7 @@
         </p:nvSpPr>
         <p:spPr>
           <a:xfrm>
-            <a:off x="4348800" y="2826000"/>
+            <a:off x="4492800" y="2826000"/>
             <a:ext cx="302400" cy="154800"/>
           </a:xfrm>
           <a:prstGeom prst="rect">
@@ -13858,7 +13858,7 @@
         </p:nvSpPr>
         <p:spPr>
           <a:xfrm>
-            <a:off x="4651200" y="2826000"/>
+            <a:off x="4795200" y="2826000"/>
             <a:ext cx="302400" cy="154800"/>
           </a:xfrm>
           <a:prstGeom prst="rect">
@@ -13903,7 +13903,7 @@
         </p:nvSpPr>
         <p:spPr>
           <a:xfrm>
-            <a:off x="3139200" y="503999"/>
+            <a:off x="3283200" y="503999"/>
             <a:ext cx="1814400" cy="2476800"/>
           </a:xfrm>
           <a:prstGeom prst="rect">
@@ -13946,7 +13946,7 @@
         </p:nvCxnSpPr>
         <p:spPr>
           <a:xfrm>
-            <a:off x="3139200" y="968400"/>
+            <a:off x="3283200" y="968400"/>
             <a:ext cx="1814400" cy="0"/>
           </a:xfrm>
           <a:prstGeom prst="line">
@@ -13981,7 +13981,7 @@
         </p:nvCxnSpPr>
         <p:spPr>
           <a:xfrm>
-            <a:off x="3139200" y="1432800"/>
+            <a:off x="3283200" y="1432800"/>
             <a:ext cx="1814400" cy="0"/>
           </a:xfrm>
           <a:prstGeom prst="line">
@@ -14016,7 +14016,7 @@
         </p:nvCxnSpPr>
         <p:spPr>
           <a:xfrm>
-            <a:off x="3139200" y="1742400"/>
+            <a:off x="3283200" y="1742400"/>
             <a:ext cx="1814400" cy="0"/>
           </a:xfrm>
           <a:prstGeom prst="line">
@@ -14051,7 +14051,7 @@
         </p:nvCxnSpPr>
         <p:spPr>
           <a:xfrm>
-            <a:off x="3139200" y="2051999"/>
+            <a:off x="3283200" y="2051999"/>
             <a:ext cx="1814400" cy="0"/>
           </a:xfrm>
           <a:prstGeom prst="line">
@@ -14086,7 +14086,7 @@
         </p:nvCxnSpPr>
         <p:spPr>
           <a:xfrm>
-            <a:off x="3139200" y="2361600"/>
+            <a:off x="3283200" y="2361600"/>
             <a:ext cx="1814400" cy="0"/>
           </a:xfrm>
           <a:prstGeom prst="line">
@@ -14121,7 +14121,7 @@
         </p:nvCxnSpPr>
         <p:spPr>
           <a:xfrm>
-            <a:off x="3139200" y="2671200"/>
+            <a:off x="3283200" y="2671200"/>
             <a:ext cx="1814400" cy="0"/>
           </a:xfrm>
           <a:prstGeom prst="line">
@@ -14156,7 +14156,7 @@
         </p:nvSpPr>
         <p:spPr>
           <a:xfrm rot="18900000">
-            <a:off x="3031200" y="2987999"/>
+            <a:off x="3175200" y="2987999"/>
             <a:ext cx="453600" cy="201600"/>
           </a:xfrm>
           <a:prstGeom prst="rect">
@@ -14202,7 +14202,7 @@
         </p:nvSpPr>
         <p:spPr>
           <a:xfrm rot="18900000">
-            <a:off x="3333600" y="2987999"/>
+            <a:off x="3477600" y="2987999"/>
             <a:ext cx="453600" cy="201600"/>
           </a:xfrm>
           <a:prstGeom prst="rect">
@@ -14248,7 +14248,7 @@
         </p:nvSpPr>
         <p:spPr>
           <a:xfrm rot="18900000">
-            <a:off x="3636000" y="2987999"/>
+            <a:off x="3780000" y="2987999"/>
             <a:ext cx="453600" cy="201600"/>
           </a:xfrm>
           <a:prstGeom prst="rect">
@@ -14294,7 +14294,7 @@
         </p:nvSpPr>
         <p:spPr>
           <a:xfrm rot="18900000">
-            <a:off x="3938400" y="2987999"/>
+            <a:off x="4082400" y="2987999"/>
             <a:ext cx="453600" cy="201600"/>
           </a:xfrm>
           <a:prstGeom prst="rect">
@@ -14341,7 +14341,7 @@
         </p:nvSpPr>
         <p:spPr>
           <a:xfrm rot="18900000">
-            <a:off x="4240800" y="2987999"/>
+            <a:off x="4384800" y="2987999"/>
             <a:ext cx="453600" cy="201600"/>
           </a:xfrm>
           <a:prstGeom prst="rect">
@@ -14388,7 +14388,7 @@
         </p:nvSpPr>
         <p:spPr>
           <a:xfrm rot="18900000">
-            <a:off x="4543200" y="2987999"/>
+            <a:off x="4687200" y="2987999"/>
             <a:ext cx="453600" cy="201600"/>
           </a:xfrm>
           <a:prstGeom prst="rect">
@@ -14435,7 +14435,7 @@
         </p:nvSpPr>
         <p:spPr>
           <a:xfrm>
-            <a:off x="5130000" y="737999"/>
+            <a:off x="5274000" y="737999"/>
             <a:ext cx="122400" cy="61200"/>
           </a:xfrm>
           <a:prstGeom prst="rect">
@@ -14480,7 +14480,7 @@
         </p:nvSpPr>
         <p:spPr>
           <a:xfrm>
-            <a:off x="5130000" y="797400"/>
+            <a:off x="5274000" y="797400"/>
             <a:ext cx="122400" cy="61200"/>
           </a:xfrm>
           <a:prstGeom prst="rect">
@@ -14525,7 +14525,7 @@
         </p:nvSpPr>
         <p:spPr>
           <a:xfrm>
-            <a:off x="5130000" y="856800"/>
+            <a:off x="5274000" y="856800"/>
             <a:ext cx="122400" cy="61200"/>
           </a:xfrm>
           <a:prstGeom prst="rect">
@@ -14570,7 +14570,7 @@
         </p:nvSpPr>
         <p:spPr>
           <a:xfrm>
-            <a:off x="5130000" y="916200"/>
+            <a:off x="5274000" y="916200"/>
             <a:ext cx="122400" cy="61200"/>
           </a:xfrm>
           <a:prstGeom prst="rect">
@@ -14615,7 +14615,7 @@
         </p:nvSpPr>
         <p:spPr>
           <a:xfrm>
-            <a:off x="5130000" y="975600"/>
+            <a:off x="5274000" y="975600"/>
             <a:ext cx="122400" cy="61200"/>
           </a:xfrm>
           <a:prstGeom prst="rect">
@@ -14660,7 +14660,7 @@
         </p:nvSpPr>
         <p:spPr>
           <a:xfrm>
-            <a:off x="5130000" y="1035000"/>
+            <a:off x="5274000" y="1035000"/>
             <a:ext cx="122400" cy="61200"/>
           </a:xfrm>
           <a:prstGeom prst="rect">
@@ -14705,7 +14705,7 @@
         </p:nvSpPr>
         <p:spPr>
           <a:xfrm>
-            <a:off x="5130000" y="1094400"/>
+            <a:off x="5274000" y="1094400"/>
             <a:ext cx="122400" cy="61200"/>
           </a:xfrm>
           <a:prstGeom prst="rect">
@@ -14750,7 +14750,7 @@
         </p:nvSpPr>
         <p:spPr>
           <a:xfrm>
-            <a:off x="5130000" y="1153800"/>
+            <a:off x="5274000" y="1153800"/>
             <a:ext cx="122400" cy="61200"/>
           </a:xfrm>
           <a:prstGeom prst="rect">
@@ -14795,7 +14795,7 @@
         </p:nvSpPr>
         <p:spPr>
           <a:xfrm>
-            <a:off x="5130000" y="1213200"/>
+            <a:off x="5274000" y="1213200"/>
             <a:ext cx="122400" cy="61200"/>
           </a:xfrm>
           <a:prstGeom prst="rect">
@@ -14840,7 +14840,7 @@
         </p:nvSpPr>
         <p:spPr>
           <a:xfrm>
-            <a:off x="5130000" y="1272600"/>
+            <a:off x="5274000" y="1272600"/>
             <a:ext cx="122400" cy="61200"/>
           </a:xfrm>
           <a:prstGeom prst="rect">
@@ -14885,7 +14885,7 @@
         </p:nvSpPr>
         <p:spPr>
           <a:xfrm>
-            <a:off x="5130000" y="1332000"/>
+            <a:off x="5274000" y="1332000"/>
             <a:ext cx="122400" cy="61200"/>
           </a:xfrm>
           <a:prstGeom prst="rect">
@@ -14930,7 +14930,7 @@
         </p:nvSpPr>
         <p:spPr>
           <a:xfrm>
-            <a:off x="5130000" y="1391400"/>
+            <a:off x="5274000" y="1391400"/>
             <a:ext cx="122400" cy="61200"/>
           </a:xfrm>
           <a:prstGeom prst="rect">
@@ -14975,7 +14975,7 @@
         </p:nvSpPr>
         <p:spPr>
           <a:xfrm>
-            <a:off x="5130000" y="1450800"/>
+            <a:off x="5274000" y="1450800"/>
             <a:ext cx="122400" cy="61200"/>
           </a:xfrm>
           <a:prstGeom prst="rect">
@@ -15020,7 +15020,7 @@
         </p:nvSpPr>
         <p:spPr>
           <a:xfrm>
-            <a:off x="5130000" y="1510200"/>
+            <a:off x="5274000" y="1510200"/>
             <a:ext cx="122400" cy="61200"/>
           </a:xfrm>
           <a:prstGeom prst="rect">
@@ -15065,7 +15065,7 @@
         </p:nvSpPr>
         <p:spPr>
           <a:xfrm>
-            <a:off x="5130000" y="1569599"/>
+            <a:off x="5274000" y="1569599"/>
             <a:ext cx="122400" cy="61200"/>
           </a:xfrm>
           <a:prstGeom prst="rect">
@@ -15110,7 +15110,7 @@
         </p:nvSpPr>
         <p:spPr>
           <a:xfrm>
-            <a:off x="5130000" y="1629000"/>
+            <a:off x="5274000" y="1629000"/>
             <a:ext cx="122400" cy="61200"/>
           </a:xfrm>
           <a:prstGeom prst="rect">
@@ -15155,7 +15155,7 @@
         </p:nvSpPr>
         <p:spPr>
           <a:xfrm>
-            <a:off x="5130000" y="1688399"/>
+            <a:off x="5274000" y="1688399"/>
             <a:ext cx="122400" cy="61200"/>
           </a:xfrm>
           <a:prstGeom prst="rect">
@@ -15200,7 +15200,7 @@
         </p:nvSpPr>
         <p:spPr>
           <a:xfrm>
-            <a:off x="5130000" y="1747800"/>
+            <a:off x="5274000" y="1747800"/>
             <a:ext cx="122400" cy="61200"/>
           </a:xfrm>
           <a:prstGeom prst="rect">
@@ -15245,7 +15245,7 @@
         </p:nvSpPr>
         <p:spPr>
           <a:xfrm>
-            <a:off x="5130000" y="1807199"/>
+            <a:off x="5274000" y="1807199"/>
             <a:ext cx="122400" cy="61200"/>
           </a:xfrm>
           <a:prstGeom prst="rect">
@@ -15290,7 +15290,7 @@
         </p:nvSpPr>
         <p:spPr>
           <a:xfrm>
-            <a:off x="5130000" y="1866599"/>
+            <a:off x="5274000" y="1866599"/>
             <a:ext cx="122400" cy="61200"/>
           </a:xfrm>
           <a:prstGeom prst="rect">
@@ -15335,7 +15335,7 @@
         </p:nvSpPr>
         <p:spPr>
           <a:xfrm>
-            <a:off x="5130000" y="1925999"/>
+            <a:off x="5274000" y="1925999"/>
             <a:ext cx="122400" cy="61200"/>
           </a:xfrm>
           <a:prstGeom prst="rect">
@@ -15380,7 +15380,7 @@
         </p:nvSpPr>
         <p:spPr>
           <a:xfrm>
-            <a:off x="5130000" y="1985400"/>
+            <a:off x="5274000" y="1985400"/>
             <a:ext cx="122400" cy="61200"/>
           </a:xfrm>
           <a:prstGeom prst="rect">
@@ -15425,7 +15425,7 @@
         </p:nvSpPr>
         <p:spPr>
           <a:xfrm>
-            <a:off x="5130000" y="2044800"/>
+            <a:off x="5274000" y="2044800"/>
             <a:ext cx="122400" cy="61200"/>
           </a:xfrm>
           <a:prstGeom prst="rect">
@@ -15470,7 +15470,7 @@
         </p:nvSpPr>
         <p:spPr>
           <a:xfrm>
-            <a:off x="5130000" y="2104200"/>
+            <a:off x="5274000" y="2104200"/>
             <a:ext cx="122400" cy="61200"/>
           </a:xfrm>
           <a:prstGeom prst="rect">
@@ -15515,7 +15515,7 @@
         </p:nvSpPr>
         <p:spPr>
           <a:xfrm>
-            <a:off x="5130000" y="2163600"/>
+            <a:off x="5274000" y="2163600"/>
             <a:ext cx="122400" cy="61200"/>
           </a:xfrm>
           <a:prstGeom prst="rect">
@@ -15560,7 +15560,7 @@
         </p:nvSpPr>
         <p:spPr>
           <a:xfrm>
-            <a:off x="5130000" y="2223000"/>
+            <a:off x="5274000" y="2223000"/>
             <a:ext cx="122400" cy="61200"/>
           </a:xfrm>
           <a:prstGeom prst="rect">
@@ -15605,7 +15605,7 @@
         </p:nvSpPr>
         <p:spPr>
           <a:xfrm>
-            <a:off x="5130000" y="2282400"/>
+            <a:off x="5274000" y="2282400"/>
             <a:ext cx="122400" cy="61200"/>
           </a:xfrm>
           <a:prstGeom prst="rect">
@@ -15650,7 +15650,7 @@
         </p:nvSpPr>
         <p:spPr>
           <a:xfrm>
-            <a:off x="5130000" y="2341800"/>
+            <a:off x="5274000" y="2341800"/>
             <a:ext cx="122400" cy="61200"/>
           </a:xfrm>
           <a:prstGeom prst="rect">
@@ -15695,7 +15695,7 @@
         </p:nvSpPr>
         <p:spPr>
           <a:xfrm>
-            <a:off x="5130000" y="2401200"/>
+            <a:off x="5274000" y="2401200"/>
             <a:ext cx="122400" cy="61200"/>
           </a:xfrm>
           <a:prstGeom prst="rect">
@@ -15740,7 +15740,7 @@
         </p:nvSpPr>
         <p:spPr>
           <a:xfrm>
-            <a:off x="5130000" y="2460600"/>
+            <a:off x="5274000" y="2460600"/>
             <a:ext cx="122400" cy="61200"/>
           </a:xfrm>
           <a:prstGeom prst="rect">
@@ -15785,7 +15785,7 @@
         </p:nvSpPr>
         <p:spPr>
           <a:xfrm>
-            <a:off x="5130000" y="737999"/>
+            <a:off x="5274000" y="737999"/>
             <a:ext cx="122400" cy="1782000"/>
           </a:xfrm>
           <a:prstGeom prst="rect">
@@ -15828,7 +15828,7 @@
         </p:nvCxnSpPr>
         <p:spPr>
           <a:xfrm>
-            <a:off x="5252400" y="737999"/>
+            <a:off x="5396400" y="737999"/>
             <a:ext cx="36000" cy="0"/>
           </a:xfrm>
           <a:prstGeom prst="line">
@@ -15863,7 +15863,7 @@
         </p:nvSpPr>
         <p:spPr>
           <a:xfrm>
-            <a:off x="5295600" y="680400"/>
+            <a:off x="5439600" y="680400"/>
             <a:ext cx="216000" cy="115200"/>
           </a:xfrm>
           <a:prstGeom prst="rect">
@@ -15908,7 +15908,7 @@
         </p:nvCxnSpPr>
         <p:spPr>
           <a:xfrm>
-            <a:off x="5252400" y="1104942"/>
+            <a:off x="5396400" y="1104942"/>
             <a:ext cx="36000" cy="0"/>
           </a:xfrm>
           <a:prstGeom prst="line">
@@ -15943,7 +15943,7 @@
         </p:nvSpPr>
         <p:spPr>
           <a:xfrm>
-            <a:off x="5295600" y="1047342"/>
+            <a:off x="5439600" y="1047342"/>
             <a:ext cx="216000" cy="115200"/>
           </a:xfrm>
           <a:prstGeom prst="rect">
@@ -15988,7 +15988,7 @@
         </p:nvCxnSpPr>
         <p:spPr>
           <a:xfrm>
-            <a:off x="5252400" y="1366971"/>
+            <a:off x="5396400" y="1366971"/>
             <a:ext cx="36000" cy="0"/>
           </a:xfrm>
           <a:prstGeom prst="line">
@@ -16023,7 +16023,7 @@
         </p:nvSpPr>
         <p:spPr>
           <a:xfrm>
-            <a:off x="5295600" y="1309371"/>
+            <a:off x="5439600" y="1309371"/>
             <a:ext cx="216000" cy="115200"/>
           </a:xfrm>
           <a:prstGeom prst="rect">
@@ -16068,7 +16068,7 @@
         </p:nvCxnSpPr>
         <p:spPr>
           <a:xfrm>
-            <a:off x="5252400" y="1629000"/>
+            <a:off x="5396400" y="1629000"/>
             <a:ext cx="36000" cy="0"/>
           </a:xfrm>
           <a:prstGeom prst="line">
@@ -16103,7 +16103,7 @@
         </p:nvSpPr>
         <p:spPr>
           <a:xfrm>
-            <a:off x="5295600" y="1571400"/>
+            <a:off x="5439600" y="1571400"/>
             <a:ext cx="216000" cy="115200"/>
           </a:xfrm>
           <a:prstGeom prst="rect">
@@ -16148,7 +16148,7 @@
         </p:nvCxnSpPr>
         <p:spPr>
           <a:xfrm>
-            <a:off x="5252400" y="1891028"/>
+            <a:off x="5396400" y="1891028"/>
             <a:ext cx="36000" cy="0"/>
           </a:xfrm>
           <a:prstGeom prst="line">
@@ -16183,7 +16183,7 @@
         </p:nvSpPr>
         <p:spPr>
           <a:xfrm>
-            <a:off x="5295600" y="1833428"/>
+            <a:off x="5439600" y="1833428"/>
             <a:ext cx="216000" cy="115200"/>
           </a:xfrm>
           <a:prstGeom prst="rect">
@@ -16228,7 +16228,7 @@
         </p:nvCxnSpPr>
         <p:spPr>
           <a:xfrm>
-            <a:off x="5252400" y="2153057"/>
+            <a:off x="5396400" y="2153057"/>
             <a:ext cx="36000" cy="0"/>
           </a:xfrm>
           <a:prstGeom prst="line">
@@ -16263,7 +16263,7 @@
         </p:nvSpPr>
         <p:spPr>
           <a:xfrm>
-            <a:off x="5295600" y="2095457"/>
+            <a:off x="5439600" y="2095457"/>
             <a:ext cx="216000" cy="115200"/>
           </a:xfrm>
           <a:prstGeom prst="rect">
@@ -16308,7 +16308,7 @@
         </p:nvCxnSpPr>
         <p:spPr>
           <a:xfrm>
-            <a:off x="5252400" y="2520000"/>
+            <a:off x="5396400" y="2520000"/>
             <a:ext cx="36000" cy="0"/>
           </a:xfrm>
           <a:prstGeom prst="line">
@@ -16343,7 +16343,7 @@
         </p:nvSpPr>
         <p:spPr>
           <a:xfrm>
-            <a:off x="5295600" y="2462400"/>
+            <a:off x="5439600" y="2462400"/>
             <a:ext cx="216000" cy="115200"/>
           </a:xfrm>
           <a:prstGeom prst="rect">
@@ -16388,7 +16388,7 @@
         </p:nvSpPr>
         <p:spPr>
           <a:xfrm>
-            <a:off x="5047200" y="583200"/>
+            <a:off x="5191200" y="583200"/>
             <a:ext cx="396000" cy="115200"/>
           </a:xfrm>
           <a:prstGeom prst="rect">
@@ -16433,7 +16433,7 @@
         </p:nvSpPr>
         <p:spPr>
           <a:xfrm>
-            <a:off x="5598000" y="720000"/>
+            <a:off x="5742000" y="720000"/>
             <a:ext cx="486000" cy="208800"/>
           </a:xfrm>
           <a:prstGeom prst="rect">
@@ -16479,7 +16479,7 @@
         </p:nvSpPr>
         <p:spPr>
           <a:xfrm>
-            <a:off x="5598000" y="2332800"/>
+            <a:off x="5742000" y="2332800"/>
             <a:ext cx="486000" cy="208800"/>
           </a:xfrm>
           <a:prstGeom prst="rect">

</xml_diff>